<commit_message>
Material executivo com o link do repositorio citado nos slides 21 e 22
</commit_message>
<xml_diff>
--- a/entregaveis/TechChallenge_Fase3_MaterialExecutivo.pptx
+++ b/entregaveis/TechChallenge_Fase3_MaterialExecutivo.pptx
@@ -1755,7 +1755,7 @@
           <a:p>
             <a:r>
               <a:rPr lang="en-US" dirty="0"/>
-              <a:t>Fechar retomando a promessa da abertura e abrir para perguntas.</a:t>
+              <a:t>Fechar retomando a promessa da abertura, citar o repositório público e abrir para perguntas.</a:t>
             </a:r>
             <a:endParaRPr lang="en-US" dirty="0"/>
           </a:p>
@@ -8722,7 +8722,7 @@
         </p:nvSpPr>
         <p:spPr>
           <a:xfrm>
-            <a:off x="502920" y="5257800"/>
+            <a:off x="502920" y="5138928"/>
             <a:ext cx="11155680" cy="365760"/>
           </a:xfrm>
           <a:prstGeom prst="rect">
@@ -8756,6 +8756,66 @@
       <p:sp>
         <p:nvSpPr>
           <p:cNvPr id="9" name="Text 7"/>
+          <p:cNvSpPr txBox="1"/>
+          <p:nvPr/>
+        </p:nvSpPr>
+        <p:spPr>
+          <a:xfrm>
+            <a:off x="502920" y="5504688"/>
+            <a:ext cx="11155680" cy="365760"/>
+          </a:xfrm>
+          <a:prstGeom prst="rect">
+            <a:avLst/>
+          </a:prstGeom>
+          <a:noFill/>
+          <a:ln/>
+        </p:spPr>
+        <p:txBody>
+          <a:bodyPr wrap="square" lIns="0" tIns="0" rIns="0" bIns="0" rtlCol="0" anchor="ctr"/>
+          <a:lstStyle/>
+          <a:p>
+            <a:pPr indent="0" marL="0">
+              <a:buNone/>
+            </a:pPr>
+            <a:r>
+              <a:rPr lang="en-US" sz="1300" dirty="0">
+                <a:solidFill>
+                  <a:srgbClr val="1A1A1A"/>
+                </a:solidFill>
+                <a:latin typeface="Calibri" pitchFamily="34" charset="0"/>
+                <a:ea typeface="Calibri" pitchFamily="34" charset="-122"/>
+                <a:cs typeface="Calibri" pitchFamily="34" charset="-120"/>
+              </a:rPr>
+              <a:t>Repositório público com todo o material: </a:t>
+            </a:r>
+            <a:pPr indent="0" marL="0">
+              <a:buNone/>
+            </a:pPr>
+            <a:r>
+              <a:rPr lang="en-US" sz="1300" u="sng" dirty="0">
+                <a:solidFill>
+                  <a:srgbClr val="4E8098"/>
+                </a:solidFill>
+                <a:latin typeface="Calibri" pitchFamily="34" charset="0"/>
+                <a:ea typeface="Calibri" pitchFamily="34" charset="-122"/>
+                <a:cs typeface="Calibri" pitchFamily="34" charset="-120"/>
+                <a:hlinkClick r:id="rId1" invalidUrl="" action="" tgtFrame="" tooltip="" history="1" highlightClick="0" endSnd="0">
+                  <a:extLst>
+                    <a:ext uri="{A12FA001-AC4F-418D-AE19-62706E023703}">
+                      <ahyp:hlinkClr xmlns:ahyp="http://schemas.microsoft.com/office/drawing/2018/hyperlinkcolor" val="tx"/>
+                    </a:ext>
+                  </a:extLst>
+                </a:hlinkClick>
+              </a:rPr>
+              <a:t>github.com/AnaPaula-Galdino/tech-challenge-fase3-state-of-data</a:t>
+            </a:r>
+            <a:endParaRPr lang="en-US" sz="1300" dirty="0"/>
+          </a:p>
+        </p:txBody>
+      </p:sp>
+      <p:sp>
+        <p:nvSpPr>
+          <p:cNvPr id="10" name="Text 8"/>
           <p:cNvSpPr txBox="1"/>
           <p:nvPr/>
         </p:nvSpPr>
@@ -8794,7 +8854,7 @@
       </p:sp>
       <p:sp>
         <p:nvSpPr>
-          <p:cNvPr id="10" name="Text 8"/>
+          <p:cNvPr id="11" name="Text 9"/>
           <p:cNvSpPr txBox="1"/>
           <p:nvPr/>
         </p:nvSpPr>
@@ -8944,6 +9004,66 @@
       <p:sp>
         <p:nvSpPr>
           <p:cNvPr id="4" name="Text 2"/>
+          <p:cNvSpPr txBox="1"/>
+          <p:nvPr/>
+        </p:nvSpPr>
+        <p:spPr>
+          <a:xfrm>
+            <a:off x="822960" y="4956048"/>
+            <a:ext cx="9601200" cy="274320"/>
+          </a:xfrm>
+          <a:prstGeom prst="rect">
+            <a:avLst/>
+          </a:prstGeom>
+          <a:noFill/>
+          <a:ln/>
+        </p:spPr>
+        <p:txBody>
+          <a:bodyPr wrap="square" lIns="0" tIns="0" rIns="0" bIns="0" rtlCol="0" anchor="ctr"/>
+          <a:lstStyle/>
+          <a:p>
+            <a:pPr indent="0" marL="0">
+              <a:buNone/>
+            </a:pPr>
+            <a:r>
+              <a:rPr lang="en-US" sz="1300" dirty="0">
+                <a:solidFill>
+                  <a:srgbClr val="FFFFFF"/>
+                </a:solidFill>
+                <a:latin typeface="Calibri" pitchFamily="34" charset="0"/>
+                <a:ea typeface="Calibri" pitchFamily="34" charset="-122"/>
+                <a:cs typeface="Calibri" pitchFamily="34" charset="-120"/>
+              </a:rPr>
+              <a:t>Todo o material, código, notebooks e documentação: </a:t>
+            </a:r>
+            <a:pPr indent="0" marL="0">
+              <a:buNone/>
+            </a:pPr>
+            <a:r>
+              <a:rPr lang="en-US" sz="1300" u="sng" dirty="0">
+                <a:solidFill>
+                  <a:srgbClr val="8FBCD4"/>
+                </a:solidFill>
+                <a:latin typeface="Calibri" pitchFamily="34" charset="0"/>
+                <a:ea typeface="Calibri" pitchFamily="34" charset="-122"/>
+                <a:cs typeface="Calibri" pitchFamily="34" charset="-120"/>
+                <a:hlinkClick r:id="rId1" invalidUrl="" action="" tgtFrame="" tooltip="" history="1" highlightClick="0" endSnd="0">
+                  <a:extLst>
+                    <a:ext uri="{A12FA001-AC4F-418D-AE19-62706E023703}">
+                      <ahyp:hlinkClr xmlns:ahyp="http://schemas.microsoft.com/office/drawing/2018/hyperlinkcolor" val="tx"/>
+                    </a:ext>
+                  </a:extLst>
+                </a:hlinkClick>
+              </a:rPr>
+              <a:t>github.com/AnaPaula-Galdino/tech-challenge-fase3-state-of-data</a:t>
+            </a:r>
+            <a:endParaRPr lang="en-US" sz="1300" dirty="0"/>
+          </a:p>
+        </p:txBody>
+      </p:sp>
+      <p:sp>
+        <p:nvSpPr>
+          <p:cNvPr id="5" name="Text 3"/>
           <p:cNvSpPr txBox="1"/>
           <p:nvPr/>
         </p:nvSpPr>

</xml_diff>

<commit_message>
Material executivo regerado, sem caminho de arquivo no texto alternativo das imagens
</commit_message>
<xml_diff>
--- a/entregaveis/TechChallenge_Fase3_MaterialExecutivo.pptx
+++ b/entregaveis/TechChallenge_Fase3_MaterialExecutivo.pptx
@@ -1667,7 +1667,7 @@
           <a:p>
             <a:r>
               <a:rPr lang="en-US" dirty="0"/>
-              <a:t>Declarar limitação antes que o avaliador pergunte é o que separa análise de opinião.</a:t>
+              <a:t>Declarar a limitação antes que alguém pergunte é o que separa análise de opinião.</a:t>
             </a:r>
             <a:endParaRPr lang="en-US" dirty="0"/>
           </a:p>
@@ -2107,7 +2107,7 @@
           <a:p>
             <a:r>
               <a:rPr lang="en-US" dirty="0"/>
-              <a:t>Este é o diferencial técnico do trabalho. Sem essa regra, toda a série histórica seria inválida sem que ninguém percebesse.</a:t>
+              <a:t>Sem essa regra, toda a série histórica seria inválida sem que ninguém percebesse. Não correr neste slide.</a:t>
             </a:r>
             <a:endParaRPr lang="en-US" dirty="0"/>
           </a:p>
@@ -3074,7 +3074,7 @@
       </p:sp>
       <p:pic>
         <p:nvPicPr>
-          <p:cNvPr id="4" name="Image 0" descr="/home/claude/fase3/figuras/deck/fig12_salario_cargo.png">    </p:cNvPr>
+          <p:cNvPr id="4" name="Image 0" descr="Engenharia de dados e machine learning lideram a mediana salarial">    </p:cNvPr>
           <p:cNvPicPr>
             <a:picLocks noChangeAspect="1"/>
           </p:cNvPicPr>
@@ -3520,7 +3520,7 @@
       </p:sp>
       <p:pic>
         <p:nvPicPr>
-          <p:cNvPr id="4" name="Image 0" descr="/home/claude/fase3/figuras/deck/fig01_genero_serie.png">    </p:cNvPr>
+          <p:cNvPr id="4" name="Image 0" descr="A participação feminina cai edição após edição, de 24,4% para 22,0%">    </p:cNvPr>
           <p:cNvPicPr>
             <a:picLocks noChangeAspect="1"/>
           </p:cNvPicPr>
@@ -3888,7 +3888,7 @@
       </p:sp>
       <p:pic>
         <p:nvPicPr>
-          <p:cNvPr id="4" name="Image 0" descr="/home/claude/fase3/figuras/deck/fig02_genero_nivel.png">    </p:cNvPr>
+          <p:cNvPr id="4" name="Image 0" descr="Proporcionalmente, mais mulheres na entrada e menos no topo">    </p:cNvPr>
           <p:cNvPicPr>
             <a:picLocks noChangeAspect="1"/>
           </p:cNvPicPr>
@@ -4256,7 +4256,7 @@
       </p:sp>
       <p:pic>
         <p:nvPicPr>
-          <p:cNvPr id="4" name="Image 0" descr="/home/claude/fase3/figuras/deck/fig07_linguagens.png">    </p:cNvPr>
+          <p:cNvPr id="4" name="Image 0" descr="Python domina e o SQL aparece ao lado dele, não no lugar">    </p:cNvPr>
           <p:cNvPicPr>
             <a:picLocks noChangeAspect="1"/>
           </p:cNvPicPr>
@@ -4624,7 +4624,7 @@
       </p:sp>
       <p:pic>
         <p:nvPicPr>
-          <p:cNvPr id="4" name="Image 0" descr="/home/claude/fase3/figuras/deck/fig13_ferramentas.png">    </p:cNvPr>
+          <p:cNvPr id="4" name="Image 0" descr="AWS lidera na nuvem e o Power BI não tem concorrente em BI">    </p:cNvPr>
           <p:cNvPicPr>
             <a:picLocks noChangeAspect="1"/>
           </p:cNvPicPr>
@@ -5070,7 +5070,7 @@
       </p:sp>
       <p:pic>
         <p:nvPicPr>
-          <p:cNvPr id="4" name="Image 0" descr="/home/claude/fase3/figuras/deck/fig06_ia_serie.png">    </p:cNvPr>
+          <p:cNvPr id="4" name="Image 0" descr="A adoção de IA quase dobrou enquanto a rejeição caiu pela metade">    </p:cNvPr>
           <p:cNvPicPr>
             <a:picLocks noChangeAspect="1"/>
           </p:cNvPicPr>
@@ -5438,7 +5438,7 @@
       </p:sp>
       <p:pic>
         <p:nvPicPr>
-          <p:cNvPr id="4" name="Image 0" descr="/home/claude/fase3/figuras/deck/fig05_ia_prioridade.png">    </p:cNvPr>
+          <p:cNvPr id="4" name="Image 0" descr="Em duas edições, a IA saiu da margem e virou pauta de orçamento">    </p:cNvPr>
           <p:cNvPicPr>
             <a:picLocks noChangeAspect="1"/>
           </p:cNvPicPr>
@@ -5806,7 +5806,7 @@
       </p:sp>
       <p:pic>
         <p:nvPicPr>
-          <p:cNvPr id="4" name="Image 0" descr="/home/claude/fase3/figuras/deck/fig11_ia_impacto.png">    </p:cNvPr>
+          <p:cNvPr id="4" name="Image 0" descr="A prioridade já virou consenso, o resultado em produção ainda não">    </p:cNvPr>
           <p:cNvPicPr>
             <a:picLocks noChangeAspect="1"/>
           </p:cNvPicPr>
@@ -6252,7 +6252,7 @@
       </p:sp>
       <p:pic>
         <p:nvPicPr>
-          <p:cNvPr id="4" name="Image 0" descr="/home/claude/fase3/figuras/deck/fig04_modelo_trabalho.png">    </p:cNvPr>
+          <p:cNvPr id="4" name="Image 0" descr="O trabalho remoto recua e o presencial avança">    </p:cNvPr>
           <p:cNvPicPr>
             <a:picLocks noChangeAspect="1"/>
           </p:cNvPicPr>
@@ -6620,7 +6620,7 @@
       </p:sp>
       <p:pic>
         <p:nvPicPr>
-          <p:cNvPr id="4" name="Image 0" descr="/home/claude/fase3/figuras/deck/fig10_satisfacao_modelo.png">    </p:cNvPr>
+          <p:cNvPr id="4" name="Image 0" descr="Flexibilidade, e não o remoto puro, separa satisfeitos de insatisfeitos">    </p:cNvPr>
           <p:cNvPicPr>
             <a:picLocks noChangeAspect="1"/>
           </p:cNvPicPr>
@@ -8846,7 +8846,7 @@
                 <a:ea typeface="Calibri" pitchFamily="34" charset="-122"/>
                 <a:cs typeface="Calibri" pitchFamily="34" charset="-120"/>
               </a:rPr>
-              <a:t>Fonte: documentação de auditoria do projeto, entregue junto com o material.</a:t>
+              <a:t>Fonte: apuração própria sobre a camada Gold, reproduzível pelos notebooks e consultas SQL entregues.</a:t>
             </a:r>
             <a:endParaRPr lang="en-US" sz="900" dirty="0"/>
           </a:p>
@@ -10664,7 +10664,7 @@
       </p:sp>
       <p:pic>
         <p:nvPicPr>
-          <p:cNvPr id="4" name="Image 0" descr="/home/claude/fase3/figuras/deck/arquitetura_aws.png">    </p:cNvPr>
+          <p:cNvPr id="4" name="Image 0" descr="Diagrama da arquitetura da solução na AWS, do arquivo de origem no Kaggle até o material executivo, passando pelas camadas Bronze, Silver e Gold no Amazon S3, pelos dois jobs do AWS Glue em PySpark, pelo Glue Data Catalog e pelo Amazon Athena.">    </p:cNvPr>
           <p:cNvPicPr>
             <a:picLocks noChangeAspect="1"/>
           </p:cNvPicPr>
@@ -11878,7 +11878,7 @@
       </p:sp>
       <p:pic>
         <p:nvPicPr>
-          <p:cNvPr id="4" name="Image 0" descr="/home/claude/fase3/figuras/deck/fig08_setor.png">    </p:cNvPr>
+          <p:cNvPr id="4" name="Image 0" descr="Finanças e tecnologia concentram mais de um terço do mercado">    </p:cNvPr>
           <p:cNvPicPr>
             <a:picLocks noChangeAspect="1"/>
           </p:cNvPicPr>
@@ -12246,7 +12246,7 @@
       </p:sp>
       <p:pic>
         <p:nvPicPr>
-          <p:cNvPr id="4" name="Image 0" descr="/home/claude/fase3/figuras/deck/fig09_regiao.png">    </p:cNvPr>
+          <p:cNvPr id="4" name="Image 0" descr="A concentração no Sudeste aumentou em vez de ceder ao trabalho remoto">    </p:cNvPr>
           <p:cNvPicPr>
             <a:picLocks noChangeAspect="1"/>
           </p:cNvPicPr>
@@ -12614,7 +12614,7 @@
       </p:sp>
       <p:pic>
         <p:nvPicPr>
-          <p:cNvPr id="4" name="Image 0" descr="/home/claude/fase3/figuras/deck/fig03_salario_nivel.png">    </p:cNvPr>
+          <p:cNvPr id="4" name="Image 0" descr="A faixa mediana do Sênior subiu 40% e as de entrada não se moveram">    </p:cNvPr>
           <p:cNvPicPr>
             <a:picLocks noChangeAspect="1"/>
           </p:cNvPicPr>

</xml_diff>